<commit_message>
add GLME-adjusted figures, grid profile system, emmeans pipeline, poster/deck updates
Co-Authored-By: Claude Opus 4.6 <noreply@anthropic.com>
</commit_message>
<xml_diff>
--- a/SocialWarden_PitchDeck.pptx
+++ b/SocialWarden_PitchDeck.pptx
@@ -5,13 +5,12 @@
     <p:sldMasterId id="2147483648" r:id="rId1"/>
   </p:sldMasterIdLst>
   <p:sldIdLst>
-    <p:sldId id="256" r:id="rId2"/>
-    <p:sldId id="257" r:id="rId3"/>
-    <p:sldId id="258" r:id="rId4"/>
-    <p:sldId id="260" r:id="rId10"/>
-    <p:sldId id="259" r:id="rId5"/>
+    <p:sldId id="256" r:id="rId7"/>
+    <p:sldId id="257" r:id="rId8"/>
+    <p:sldId id="258" r:id="rId9"/>
+    <p:sldId id="259" r:id="rId10"/>
   </p:sldIdLst>
-  <p:sldSz cx="12192000" cy="6858000"/>
+  <p:sldSz cx="12191695" cy="6858000" type="screen4x3"/>
   <p:notesSz cx="6858000" cy="9144000"/>
   <p:defaultTextStyle>
     <a:defPPr>
@@ -108,22 +107,6 @@
       </a:defRPr>
     </a:lvl9pPr>
   </p:defaultTextStyle>
-  <p:extLst>
-    <p:ext uri="{EFAFB233-063F-42B5-8137-9DF3F51BA10A}">
-      <p15:sldGuideLst xmlns:p15="http://schemas.microsoft.com/office/powerpoint/2012/main">
-        <p15:guide id="1" orient="horz" pos="2160">
-          <p15:clr>
-            <a:srgbClr val="A4A3A4"/>
-          </p15:clr>
-        </p15:guide>
-        <p15:guide id="2" pos="2880">
-          <p15:clr>
-            <a:srgbClr val="A4A3A4"/>
-          </p15:clr>
-        </p15:guide>
-      </p15:sldGuideLst>
-    </p:ext>
-  </p:extLst>
 </p:presentation>
 </file>
 
@@ -165,9 +148,10 @@
           <a:lstStyle/>
           <a:p>
             <a:r>
-              <a:rPr lang="en-US"/>
+              <a:rPr lang="en-US" smtClean="0"/>
               <a:t>Click to edit Master title style</a:t>
             </a:r>
+            <a:endParaRPr lang="en-US"/>
           </a:p>
         </p:txBody>
       </p:sp>
@@ -283,9 +267,10 @@
           </a:lstStyle>
           <a:p>
             <a:r>
-              <a:rPr lang="en-US"/>
+              <a:rPr lang="en-US" smtClean="0"/>
               <a:t>Click to edit Master subtitle style</a:t>
             </a:r>
+            <a:endParaRPr lang="en-US"/>
           </a:p>
         </p:txBody>
       </p:sp>
@@ -306,7 +291,7 @@
           <a:p>
             <a:fld id="{5BCAD085-E8A6-8845-BD4E-CB4CCA059FC4}" type="datetimeFigureOut">
               <a:rPr lang="en-US" smtClean="0"/>
-              <a:t>3/17/26</a:t>
+              <a:t>1/27/13</a:t>
             </a:fld>
             <a:endParaRPr lang="en-US"/>
           </a:p>
@@ -400,9 +385,10 @@
           <a:lstStyle/>
           <a:p>
             <a:r>
-              <a:rPr lang="en-US"/>
+              <a:rPr lang="en-US" smtClean="0"/>
               <a:t>Click to edit Master title style</a:t>
             </a:r>
+            <a:endParaRPr lang="en-US"/>
           </a:p>
         </p:txBody>
       </p:sp>
@@ -423,37 +409,38 @@
           <a:p>
             <a:pPr lvl="0"/>
             <a:r>
-              <a:rPr lang="en-US"/>
+              <a:rPr lang="en-US" smtClean="0"/>
               <a:t>Click to edit Master text styles</a:t>
             </a:r>
           </a:p>
           <a:p>
             <a:pPr lvl="1"/>
             <a:r>
-              <a:rPr lang="en-US"/>
+              <a:rPr lang="en-US" smtClean="0"/>
               <a:t>Second level</a:t>
             </a:r>
           </a:p>
           <a:p>
             <a:pPr lvl="2"/>
             <a:r>
-              <a:rPr lang="en-US"/>
+              <a:rPr lang="en-US" smtClean="0"/>
               <a:t>Third level</a:t>
             </a:r>
           </a:p>
           <a:p>
             <a:pPr lvl="3"/>
             <a:r>
-              <a:rPr lang="en-US"/>
+              <a:rPr lang="en-US" smtClean="0"/>
               <a:t>Fourth level</a:t>
             </a:r>
           </a:p>
           <a:p>
             <a:pPr lvl="4"/>
             <a:r>
-              <a:rPr lang="en-US"/>
+              <a:rPr lang="en-US" smtClean="0"/>
               <a:t>Fifth level</a:t>
             </a:r>
+            <a:endParaRPr lang="en-US"/>
           </a:p>
         </p:txBody>
       </p:sp>
@@ -474,7 +461,7 @@
           <a:p>
             <a:fld id="{5BCAD085-E8A6-8845-BD4E-CB4CCA059FC4}" type="datetimeFigureOut">
               <a:rPr lang="en-US" smtClean="0"/>
-              <a:t>3/17/26</a:t>
+              <a:t>1/27/13</a:t>
             </a:fld>
             <a:endParaRPr lang="en-US"/>
           </a:p>
@@ -573,9 +560,10 @@
           <a:lstStyle/>
           <a:p>
             <a:r>
-              <a:rPr lang="en-US"/>
+              <a:rPr lang="en-US" smtClean="0"/>
               <a:t>Click to edit Master title style</a:t>
             </a:r>
+            <a:endParaRPr lang="en-US"/>
           </a:p>
         </p:txBody>
       </p:sp>
@@ -601,37 +589,38 @@
           <a:p>
             <a:pPr lvl="0"/>
             <a:r>
-              <a:rPr lang="en-US"/>
+              <a:rPr lang="en-US" smtClean="0"/>
               <a:t>Click to edit Master text styles</a:t>
             </a:r>
           </a:p>
           <a:p>
             <a:pPr lvl="1"/>
             <a:r>
-              <a:rPr lang="en-US"/>
+              <a:rPr lang="en-US" smtClean="0"/>
               <a:t>Second level</a:t>
             </a:r>
           </a:p>
           <a:p>
             <a:pPr lvl="2"/>
             <a:r>
-              <a:rPr lang="en-US"/>
+              <a:rPr lang="en-US" smtClean="0"/>
               <a:t>Third level</a:t>
             </a:r>
           </a:p>
           <a:p>
             <a:pPr lvl="3"/>
             <a:r>
-              <a:rPr lang="en-US"/>
+              <a:rPr lang="en-US" smtClean="0"/>
               <a:t>Fourth level</a:t>
             </a:r>
           </a:p>
           <a:p>
             <a:pPr lvl="4"/>
             <a:r>
-              <a:rPr lang="en-US"/>
+              <a:rPr lang="en-US" smtClean="0"/>
               <a:t>Fifth level</a:t>
             </a:r>
+            <a:endParaRPr lang="en-US"/>
           </a:p>
         </p:txBody>
       </p:sp>
@@ -652,7 +641,7 @@
           <a:p>
             <a:fld id="{5BCAD085-E8A6-8845-BD4E-CB4CCA059FC4}" type="datetimeFigureOut">
               <a:rPr lang="en-US" smtClean="0"/>
-              <a:t>3/17/26</a:t>
+              <a:t>1/27/13</a:t>
             </a:fld>
             <a:endParaRPr lang="en-US"/>
           </a:p>
@@ -746,9 +735,10 @@
           <a:lstStyle/>
           <a:p>
             <a:r>
-              <a:rPr lang="en-US"/>
+              <a:rPr lang="en-US" smtClean="0"/>
               <a:t>Click to edit Master title style</a:t>
             </a:r>
+            <a:endParaRPr lang="en-US"/>
           </a:p>
         </p:txBody>
       </p:sp>
@@ -769,37 +759,38 @@
           <a:p>
             <a:pPr lvl="0"/>
             <a:r>
-              <a:rPr lang="en-US"/>
+              <a:rPr lang="en-US" smtClean="0"/>
               <a:t>Click to edit Master text styles</a:t>
             </a:r>
           </a:p>
           <a:p>
             <a:pPr lvl="1"/>
             <a:r>
-              <a:rPr lang="en-US"/>
+              <a:rPr lang="en-US" smtClean="0"/>
               <a:t>Second level</a:t>
             </a:r>
           </a:p>
           <a:p>
             <a:pPr lvl="2"/>
             <a:r>
-              <a:rPr lang="en-US"/>
+              <a:rPr lang="en-US" smtClean="0"/>
               <a:t>Third level</a:t>
             </a:r>
           </a:p>
           <a:p>
             <a:pPr lvl="3"/>
             <a:r>
-              <a:rPr lang="en-US"/>
+              <a:rPr lang="en-US" smtClean="0"/>
               <a:t>Fourth level</a:t>
             </a:r>
           </a:p>
           <a:p>
             <a:pPr lvl="4"/>
             <a:r>
-              <a:rPr lang="en-US"/>
+              <a:rPr lang="en-US" smtClean="0"/>
               <a:t>Fifth level</a:t>
             </a:r>
+            <a:endParaRPr lang="en-US"/>
           </a:p>
         </p:txBody>
       </p:sp>
@@ -820,7 +811,7 @@
           <a:p>
             <a:fld id="{5BCAD085-E8A6-8845-BD4E-CB4CCA059FC4}" type="datetimeFigureOut">
               <a:rPr lang="en-US" smtClean="0"/>
-              <a:t>3/17/26</a:t>
+              <a:t>1/27/13</a:t>
             </a:fld>
             <a:endParaRPr lang="en-US"/>
           </a:p>
@@ -923,9 +914,10 @@
           </a:lstStyle>
           <a:p>
             <a:r>
-              <a:rPr lang="en-US"/>
+              <a:rPr lang="en-US" smtClean="0"/>
               <a:t>Click to edit Master title style</a:t>
             </a:r>
+            <a:endParaRPr lang="en-US"/>
           </a:p>
         </p:txBody>
       </p:sp>
@@ -1042,7 +1034,7 @@
           <a:p>
             <a:pPr lvl="0"/>
             <a:r>
-              <a:rPr lang="en-US"/>
+              <a:rPr lang="en-US" smtClean="0"/>
               <a:t>Click to edit Master text styles</a:t>
             </a:r>
           </a:p>
@@ -1065,7 +1057,7 @@
           <a:p>
             <a:fld id="{5BCAD085-E8A6-8845-BD4E-CB4CCA059FC4}" type="datetimeFigureOut">
               <a:rPr lang="en-US" smtClean="0"/>
-              <a:t>3/17/26</a:t>
+              <a:t>1/27/13</a:t>
             </a:fld>
             <a:endParaRPr lang="en-US"/>
           </a:p>
@@ -1159,9 +1151,10 @@
           <a:lstStyle/>
           <a:p>
             <a:r>
-              <a:rPr lang="en-US"/>
+              <a:rPr lang="en-US" smtClean="0"/>
               <a:t>Click to edit Master title style</a:t>
             </a:r>
+            <a:endParaRPr lang="en-US"/>
           </a:p>
         </p:txBody>
       </p:sp>
@@ -1215,37 +1208,38 @@
           <a:p>
             <a:pPr lvl="0"/>
             <a:r>
-              <a:rPr lang="en-US"/>
+              <a:rPr lang="en-US" smtClean="0"/>
               <a:t>Click to edit Master text styles</a:t>
             </a:r>
           </a:p>
           <a:p>
             <a:pPr lvl="1"/>
             <a:r>
-              <a:rPr lang="en-US"/>
+              <a:rPr lang="en-US" smtClean="0"/>
               <a:t>Second level</a:t>
             </a:r>
           </a:p>
           <a:p>
             <a:pPr lvl="2"/>
             <a:r>
-              <a:rPr lang="en-US"/>
+              <a:rPr lang="en-US" smtClean="0"/>
               <a:t>Third level</a:t>
             </a:r>
           </a:p>
           <a:p>
             <a:pPr lvl="3"/>
             <a:r>
-              <a:rPr lang="en-US"/>
+              <a:rPr lang="en-US" smtClean="0"/>
               <a:t>Fourth level</a:t>
             </a:r>
           </a:p>
           <a:p>
             <a:pPr lvl="4"/>
             <a:r>
-              <a:rPr lang="en-US"/>
+              <a:rPr lang="en-US" smtClean="0"/>
               <a:t>Fifth level</a:t>
             </a:r>
+            <a:endParaRPr lang="en-US"/>
           </a:p>
         </p:txBody>
       </p:sp>
@@ -1299,37 +1293,38 @@
           <a:p>
             <a:pPr lvl="0"/>
             <a:r>
-              <a:rPr lang="en-US"/>
+              <a:rPr lang="en-US" smtClean="0"/>
               <a:t>Click to edit Master text styles</a:t>
             </a:r>
           </a:p>
           <a:p>
             <a:pPr lvl="1"/>
             <a:r>
-              <a:rPr lang="en-US"/>
+              <a:rPr lang="en-US" smtClean="0"/>
               <a:t>Second level</a:t>
             </a:r>
           </a:p>
           <a:p>
             <a:pPr lvl="2"/>
             <a:r>
-              <a:rPr lang="en-US"/>
+              <a:rPr lang="en-US" smtClean="0"/>
               <a:t>Third level</a:t>
             </a:r>
           </a:p>
           <a:p>
             <a:pPr lvl="3"/>
             <a:r>
-              <a:rPr lang="en-US"/>
+              <a:rPr lang="en-US" smtClean="0"/>
               <a:t>Fourth level</a:t>
             </a:r>
           </a:p>
           <a:p>
             <a:pPr lvl="4"/>
             <a:r>
-              <a:rPr lang="en-US"/>
+              <a:rPr lang="en-US" smtClean="0"/>
               <a:t>Fifth level</a:t>
             </a:r>
+            <a:endParaRPr lang="en-US"/>
           </a:p>
         </p:txBody>
       </p:sp>
@@ -1350,7 +1345,7 @@
           <a:p>
             <a:fld id="{5BCAD085-E8A6-8845-BD4E-CB4CCA059FC4}" type="datetimeFigureOut">
               <a:rPr lang="en-US" smtClean="0"/>
-              <a:t>3/17/26</a:t>
+              <a:t>1/27/13</a:t>
             </a:fld>
             <a:endParaRPr lang="en-US"/>
           </a:p>
@@ -1448,9 +1443,10 @@
           </a:lstStyle>
           <a:p>
             <a:r>
-              <a:rPr lang="en-US"/>
+              <a:rPr lang="en-US" smtClean="0"/>
               <a:t>Click to edit Master title style</a:t>
             </a:r>
+            <a:endParaRPr lang="en-US"/>
           </a:p>
         </p:txBody>
       </p:sp>
@@ -1513,7 +1509,7 @@
           <a:p>
             <a:pPr lvl="0"/>
             <a:r>
-              <a:rPr lang="en-US"/>
+              <a:rPr lang="en-US" smtClean="0"/>
               <a:t>Click to edit Master text styles</a:t>
             </a:r>
           </a:p>
@@ -1569,37 +1565,38 @@
           <a:p>
             <a:pPr lvl="0"/>
             <a:r>
-              <a:rPr lang="en-US"/>
+              <a:rPr lang="en-US" smtClean="0"/>
               <a:t>Click to edit Master text styles</a:t>
             </a:r>
           </a:p>
           <a:p>
             <a:pPr lvl="1"/>
             <a:r>
-              <a:rPr lang="en-US"/>
+              <a:rPr lang="en-US" smtClean="0"/>
               <a:t>Second level</a:t>
             </a:r>
           </a:p>
           <a:p>
             <a:pPr lvl="2"/>
             <a:r>
-              <a:rPr lang="en-US"/>
+              <a:rPr lang="en-US" smtClean="0"/>
               <a:t>Third level</a:t>
             </a:r>
           </a:p>
           <a:p>
             <a:pPr lvl="3"/>
             <a:r>
-              <a:rPr lang="en-US"/>
+              <a:rPr lang="en-US" smtClean="0"/>
               <a:t>Fourth level</a:t>
             </a:r>
           </a:p>
           <a:p>
             <a:pPr lvl="4"/>
             <a:r>
-              <a:rPr lang="en-US"/>
+              <a:rPr lang="en-US" smtClean="0"/>
               <a:t>Fifth level</a:t>
             </a:r>
+            <a:endParaRPr lang="en-US"/>
           </a:p>
         </p:txBody>
       </p:sp>
@@ -1662,7 +1659,7 @@
           <a:p>
             <a:pPr lvl="0"/>
             <a:r>
-              <a:rPr lang="en-US"/>
+              <a:rPr lang="en-US" smtClean="0"/>
               <a:t>Click to edit Master text styles</a:t>
             </a:r>
           </a:p>
@@ -1718,37 +1715,38 @@
           <a:p>
             <a:pPr lvl="0"/>
             <a:r>
-              <a:rPr lang="en-US"/>
+              <a:rPr lang="en-US" smtClean="0"/>
               <a:t>Click to edit Master text styles</a:t>
             </a:r>
           </a:p>
           <a:p>
             <a:pPr lvl="1"/>
             <a:r>
-              <a:rPr lang="en-US"/>
+              <a:rPr lang="en-US" smtClean="0"/>
               <a:t>Second level</a:t>
             </a:r>
           </a:p>
           <a:p>
             <a:pPr lvl="2"/>
             <a:r>
-              <a:rPr lang="en-US"/>
+              <a:rPr lang="en-US" smtClean="0"/>
               <a:t>Third level</a:t>
             </a:r>
           </a:p>
           <a:p>
             <a:pPr lvl="3"/>
             <a:r>
-              <a:rPr lang="en-US"/>
+              <a:rPr lang="en-US" smtClean="0"/>
               <a:t>Fourth level</a:t>
             </a:r>
           </a:p>
           <a:p>
             <a:pPr lvl="4"/>
             <a:r>
-              <a:rPr lang="en-US"/>
+              <a:rPr lang="en-US" smtClean="0"/>
               <a:t>Fifth level</a:t>
             </a:r>
+            <a:endParaRPr lang="en-US"/>
           </a:p>
         </p:txBody>
       </p:sp>
@@ -1769,7 +1767,7 @@
           <a:p>
             <a:fld id="{5BCAD085-E8A6-8845-BD4E-CB4CCA059FC4}" type="datetimeFigureOut">
               <a:rPr lang="en-US" smtClean="0"/>
-              <a:t>3/17/26</a:t>
+              <a:t>1/27/13</a:t>
             </a:fld>
             <a:endParaRPr lang="en-US"/>
           </a:p>
@@ -1863,9 +1861,10 @@
           <a:lstStyle/>
           <a:p>
             <a:r>
-              <a:rPr lang="en-US"/>
+              <a:rPr lang="en-US" smtClean="0"/>
               <a:t>Click to edit Master title style</a:t>
             </a:r>
+            <a:endParaRPr lang="en-US"/>
           </a:p>
         </p:txBody>
       </p:sp>
@@ -1886,7 +1885,7 @@
           <a:p>
             <a:fld id="{5BCAD085-E8A6-8845-BD4E-CB4CCA059FC4}" type="datetimeFigureOut">
               <a:rPr lang="en-US" smtClean="0"/>
-              <a:t>3/17/26</a:t>
+              <a:t>1/27/13</a:t>
             </a:fld>
             <a:endParaRPr lang="en-US"/>
           </a:p>
@@ -1981,7 +1980,7 @@
           <a:p>
             <a:fld id="{5BCAD085-E8A6-8845-BD4E-CB4CCA059FC4}" type="datetimeFigureOut">
               <a:rPr lang="en-US" smtClean="0"/>
-              <a:t>3/17/26</a:t>
+              <a:t>1/27/13</a:t>
             </a:fld>
             <a:endParaRPr lang="en-US"/>
           </a:p>
@@ -2084,9 +2083,10 @@
           </a:lstStyle>
           <a:p>
             <a:r>
-              <a:rPr lang="en-US"/>
+              <a:rPr lang="en-US" smtClean="0"/>
               <a:t>Click to edit Master title style</a:t>
             </a:r>
+            <a:endParaRPr lang="en-US"/>
           </a:p>
         </p:txBody>
       </p:sp>
@@ -2140,37 +2140,38 @@
           <a:p>
             <a:pPr lvl="0"/>
             <a:r>
-              <a:rPr lang="en-US"/>
+              <a:rPr lang="en-US" smtClean="0"/>
               <a:t>Click to edit Master text styles</a:t>
             </a:r>
           </a:p>
           <a:p>
             <a:pPr lvl="1"/>
             <a:r>
-              <a:rPr lang="en-US"/>
+              <a:rPr lang="en-US" smtClean="0"/>
               <a:t>Second level</a:t>
             </a:r>
           </a:p>
           <a:p>
             <a:pPr lvl="2"/>
             <a:r>
-              <a:rPr lang="en-US"/>
+              <a:rPr lang="en-US" smtClean="0"/>
               <a:t>Third level</a:t>
             </a:r>
           </a:p>
           <a:p>
             <a:pPr lvl="3"/>
             <a:r>
-              <a:rPr lang="en-US"/>
+              <a:rPr lang="en-US" smtClean="0"/>
               <a:t>Fourth level</a:t>
             </a:r>
           </a:p>
           <a:p>
             <a:pPr lvl="4"/>
             <a:r>
-              <a:rPr lang="en-US"/>
+              <a:rPr lang="en-US" smtClean="0"/>
               <a:t>Fifth level</a:t>
             </a:r>
+            <a:endParaRPr lang="en-US"/>
           </a:p>
         </p:txBody>
       </p:sp>
@@ -2233,7 +2234,7 @@
           <a:p>
             <a:pPr lvl="0"/>
             <a:r>
-              <a:rPr lang="en-US"/>
+              <a:rPr lang="en-US" smtClean="0"/>
               <a:t>Click to edit Master text styles</a:t>
             </a:r>
           </a:p>
@@ -2256,7 +2257,7 @@
           <a:p>
             <a:fld id="{5BCAD085-E8A6-8845-BD4E-CB4CCA059FC4}" type="datetimeFigureOut">
               <a:rPr lang="en-US" smtClean="0"/>
-              <a:t>3/17/26</a:t>
+              <a:t>1/27/13</a:t>
             </a:fld>
             <a:endParaRPr lang="en-US"/>
           </a:p>
@@ -2359,9 +2360,10 @@
           </a:lstStyle>
           <a:p>
             <a:r>
-              <a:rPr lang="en-US"/>
+              <a:rPr lang="en-US" smtClean="0"/>
               <a:t>Click to edit Master title style</a:t>
             </a:r>
+            <a:endParaRPr lang="en-US"/>
           </a:p>
         </p:txBody>
       </p:sp>
@@ -2485,7 +2487,7 @@
           <a:p>
             <a:pPr lvl="0"/>
             <a:r>
-              <a:rPr lang="en-US"/>
+              <a:rPr lang="en-US" smtClean="0"/>
               <a:t>Click to edit Master text styles</a:t>
             </a:r>
           </a:p>
@@ -2508,7 +2510,7 @@
           <a:p>
             <a:fld id="{5BCAD085-E8A6-8845-BD4E-CB4CCA059FC4}" type="datetimeFigureOut">
               <a:rPr lang="en-US" smtClean="0"/>
-              <a:t>3/17/26</a:t>
+              <a:t>1/27/13</a:t>
             </a:fld>
             <a:endParaRPr lang="en-US"/>
           </a:p>
@@ -2617,9 +2619,10 @@
           <a:lstStyle/>
           <a:p>
             <a:r>
-              <a:rPr lang="en-US"/>
+              <a:rPr lang="en-US" smtClean="0"/>
               <a:t>Click to edit Master title style</a:t>
             </a:r>
+            <a:endParaRPr lang="en-US"/>
           </a:p>
         </p:txBody>
       </p:sp>
@@ -2650,37 +2653,38 @@
           <a:p>
             <a:pPr lvl="0"/>
             <a:r>
-              <a:rPr lang="en-US"/>
+              <a:rPr lang="en-US" smtClean="0"/>
               <a:t>Click to edit Master text styles</a:t>
             </a:r>
           </a:p>
           <a:p>
             <a:pPr lvl="1"/>
             <a:r>
-              <a:rPr lang="en-US"/>
+              <a:rPr lang="en-US" smtClean="0"/>
               <a:t>Second level</a:t>
             </a:r>
           </a:p>
           <a:p>
             <a:pPr lvl="2"/>
             <a:r>
-              <a:rPr lang="en-US"/>
+              <a:rPr lang="en-US" smtClean="0"/>
               <a:t>Third level</a:t>
             </a:r>
           </a:p>
           <a:p>
             <a:pPr lvl="3"/>
             <a:r>
-              <a:rPr lang="en-US"/>
+              <a:rPr lang="en-US" smtClean="0"/>
               <a:t>Fourth level</a:t>
             </a:r>
           </a:p>
           <a:p>
             <a:pPr lvl="4"/>
             <a:r>
-              <a:rPr lang="en-US"/>
+              <a:rPr lang="en-US" smtClean="0"/>
               <a:t>Fifth level</a:t>
             </a:r>
+            <a:endParaRPr lang="en-US"/>
           </a:p>
         </p:txBody>
       </p:sp>
@@ -2719,7 +2723,7 @@
           <a:p>
             <a:fld id="{5BCAD085-E8A6-8845-BD4E-CB4CCA059FC4}" type="datetimeFigureOut">
               <a:rPr lang="en-US" smtClean="0"/>
-              <a:t>3/17/26</a:t>
+              <a:t>1/27/13</a:t>
             </a:fld>
             <a:endParaRPr lang="en-US"/>
           </a:p>
@@ -3078,7 +3082,7 @@
 </file>
 
 <file path=ppt/slides/slide1.xml><?xml version="1.0" encoding="utf-8"?>
-<p:sld xmlns:a="http://schemas.openxmlformats.org/drawingml/2006/main" xmlns:r="http://schemas.openxmlformats.org/officeDocument/2006/relationships" xmlns:p="http://schemas.openxmlformats.org/presentationml/2006/main">
+<p:sld xmlns:a="http://schemas.openxmlformats.org/drawingml/2006/main" xmlns:p="http://schemas.openxmlformats.org/presentationml/2006/main" xmlns:r="http://schemas.openxmlformats.org/officeDocument/2006/relationships">
   <p:cSld>
     <p:bg>
       <p:bgPr>
@@ -3094,14 +3098,7 @@
         <p:cNvGrpSpPr/>
         <p:nvPr/>
       </p:nvGrpSpPr>
-      <p:grpSpPr>
-        <a:xfrm>
-          <a:off x="0" y="0"/>
-          <a:ext cx="0" cy="0"/>
-          <a:chOff x="0" y="0"/>
-          <a:chExt cx="0" cy="0"/>
-        </a:xfrm>
-      </p:grpSpPr>
+      <p:grpSpPr/>
       <p:sp>
         <p:nvSpPr>
           <p:cNvPr id="2" name="Rectangle 1"/>
@@ -3142,7 +3139,6 @@
           <a:lstStyle/>
           <a:p>
             <a:pPr algn="ctr"/>
-            <a:endParaRPr/>
           </a:p>
         </p:txBody>
       </p:sp>
@@ -3263,7 +3259,7 @@
         <p:spPr>
           <a:xfrm>
             <a:off x="822960" y="3291840"/>
-            <a:ext cx="10058400" cy="338554"/>
+            <a:ext cx="10058400" cy="365760"/>
           </a:xfrm>
           <a:prstGeom prst="rect">
             <a:avLst/>
@@ -3276,7 +3272,7 @@
           </a:bodyPr>
           <a:lstStyle/>
           <a:p>
-            <a:pPr>
+            <a:pPr algn="l">
               <a:defRPr sz="1600" b="0">
                 <a:solidFill>
                   <a:srgbClr val="666677"/>
@@ -3285,24 +3281,7 @@
               </a:defRPr>
             </a:pPr>
             <a:r>
-              <a:rPr dirty="0"/>
-              <a:t>Scott Blain*  ·  Lennart Wachowiak* </a:t>
-            </a:r>
-            <a:r>
-              <a:rPr lang="en-US" dirty="0"/>
-              <a:t> ·  David Williams-King  ·  Samuele Marro    </a:t>
-            </a:r>
-            <a:r>
-              <a:rPr dirty="0"/>
-              <a:t>|  </a:t>
-            </a:r>
-            <a:r>
-              <a:rPr lang="en-US" dirty="0"/>
-              <a:t> </a:t>
-            </a:r>
-            <a:r>
-              <a:rPr dirty="0"/>
-              <a:t>ERA Fellowship, March 2026</a:t>
+              <a:t>Scott Blain*  ·  Lennart Wachowiak*   |   ERA Fellowship, March 2026</a:t>
             </a:r>
           </a:p>
         </p:txBody>
@@ -3385,7 +3364,6 @@
           <a:lstStyle/>
           <a:p>
             <a:pPr algn="ctr"/>
-            <a:endParaRPr/>
           </a:p>
         </p:txBody>
       </p:sp>
@@ -3434,7 +3412,7 @@
         <p:spPr>
           <a:xfrm>
             <a:off x="1051560" y="4754880"/>
-            <a:ext cx="4572000" cy="1502976"/>
+            <a:ext cx="4572000" cy="1645920"/>
           </a:xfrm>
           <a:prstGeom prst="rect">
             <a:avLst/>
@@ -3462,24 +3440,7 @@
               </a:defRPr>
             </a:pPr>
             <a:r>
-              <a:rPr dirty="0"/>
-              <a:t>• </a:t>
-            </a:r>
-            <a:r>
-              <a:rPr lang="en-US" dirty="0"/>
-              <a:t> </a:t>
-            </a:r>
-            <a:r>
-              <a:rPr dirty="0"/>
-              <a:t>LLMs</a:t>
-            </a:r>
-            <a:r>
-              <a:rPr lang="en-US" dirty="0"/>
-              <a:t> are</a:t>
-            </a:r>
-            <a:r>
-              <a:rPr dirty="0"/>
-              <a:t> acquiring social reasoning — theory of mind,</a:t>
+              <a:t>•  LLMs acquiring social reasoning — theory of mind,</a:t>
             </a:r>
           </a:p>
           <a:p>
@@ -3498,7 +3459,6 @@
               </a:defRPr>
             </a:pPr>
             <a:r>
-              <a:rPr dirty="0"/>
               <a:t>   strategic communication, persuasive language</a:t>
             </a:r>
           </a:p>
@@ -3518,16 +3478,7 @@
               </a:defRPr>
             </a:pPr>
             <a:r>
-              <a:rPr dirty="0"/>
-              <a:t>• </a:t>
-            </a:r>
-            <a:r>
-              <a:rPr lang="en-US" dirty="0"/>
-              <a:t> Overlapping</a:t>
-            </a:r>
-            <a:r>
-              <a:rPr dirty="0"/>
-              <a:t> mechanisms enable manipulation,</a:t>
+              <a:t>•  Same mechanisms enable manipulation,</a:t>
             </a:r>
           </a:p>
           <a:p>
@@ -3546,7 +3497,6 @@
               </a:defRPr>
             </a:pPr>
             <a:r>
-              <a:rPr dirty="0"/>
               <a:t>   social engineering, and preference shaping</a:t>
             </a:r>
           </a:p>
@@ -3566,16 +3516,7 @@
               </a:defRPr>
             </a:pPr>
             <a:r>
-              <a:rPr dirty="0"/>
-              <a:t>• </a:t>
-            </a:r>
-            <a:r>
-              <a:rPr lang="en-US" dirty="0"/>
-              <a:t> </a:t>
-            </a:r>
-            <a:r>
-              <a:rPr dirty="0"/>
-              <a:t>A manipulative AI may outperform its human target</a:t>
+              <a:t>•  A manipulative AI may outperform its human target</a:t>
             </a:r>
           </a:p>
         </p:txBody>
@@ -3622,7 +3563,6 @@
           <a:lstStyle/>
           <a:p>
             <a:pPr algn="ctr"/>
-            <a:endParaRPr/>
           </a:p>
         </p:txBody>
       </p:sp>
@@ -3825,7 +3765,7 @@
 </file>
 
 <file path=ppt/slides/slide2.xml><?xml version="1.0" encoding="utf-8"?>
-<p:sld xmlns:a="http://schemas.openxmlformats.org/drawingml/2006/main" xmlns:r="http://schemas.openxmlformats.org/officeDocument/2006/relationships" xmlns:p="http://schemas.openxmlformats.org/presentationml/2006/main">
+<p:sld xmlns:a="http://schemas.openxmlformats.org/drawingml/2006/main" xmlns:p="http://schemas.openxmlformats.org/presentationml/2006/main" xmlns:r="http://schemas.openxmlformats.org/officeDocument/2006/relationships">
   <p:cSld>
     <p:bg>
       <p:bgPr>
@@ -3841,14 +3781,7 @@
         <p:cNvGrpSpPr/>
         <p:nvPr/>
       </p:nvGrpSpPr>
-      <p:grpSpPr>
-        <a:xfrm>
-          <a:off x="0" y="0"/>
-          <a:ext cx="0" cy="0"/>
-          <a:chOff x="0" y="0"/>
-          <a:chExt cx="0" cy="0"/>
-        </a:xfrm>
-      </p:grpSpPr>
+      <p:grpSpPr/>
       <p:sp>
         <p:nvSpPr>
           <p:cNvPr id="2" name="Rectangle 1"/>
@@ -3889,7 +3822,6 @@
           <a:lstStyle/>
           <a:p>
             <a:pPr algn="ctr"/>
-            <a:endParaRPr/>
           </a:p>
         </p:txBody>
       </p:sp>
@@ -4007,7 +3939,6 @@
           <a:lstStyle/>
           <a:p>
             <a:pPr algn="ctr"/>
-            <a:endParaRPr/>
           </a:p>
         </p:txBody>
       </p:sp>
@@ -4150,7 +4081,6 @@
           <a:lstStyle/>
           <a:p>
             <a:pPr algn="ctr"/>
-            <a:endParaRPr/>
           </a:p>
         </p:txBody>
       </p:sp>
@@ -4293,7 +4223,6 @@
           <a:lstStyle/>
           <a:p>
             <a:pPr algn="ctr"/>
-            <a:endParaRPr/>
           </a:p>
         </p:txBody>
       </p:sp>
@@ -4436,7 +4365,6 @@
           <a:lstStyle/>
           <a:p>
             <a:pPr algn="ctr"/>
-            <a:endParaRPr/>
           </a:p>
         </p:txBody>
       </p:sp>
@@ -4546,7 +4474,7 @@
         <p:spPr>
           <a:xfrm>
             <a:off x="822960" y="2743200"/>
-            <a:ext cx="5029200" cy="3898275"/>
+            <a:ext cx="5029200" cy="3749039"/>
           </a:xfrm>
           <a:prstGeom prst="roundRect">
             <a:avLst>
@@ -4579,7 +4507,6 @@
           <a:lstStyle/>
           <a:p>
             <a:pPr algn="ctr"/>
-            <a:endParaRPr/>
           </a:p>
         </p:txBody>
       </p:sp>
@@ -4693,7 +4620,6 @@
                 <a:latin typeface="Calibri"/>
               </a:defRPr>
             </a:pPr>
-            <a:endParaRPr/>
           </a:p>
           <a:p>
             <a:pPr algn="l">
@@ -4748,7 +4674,6 @@
                 <a:latin typeface="Calibri"/>
               </a:defRPr>
             </a:pPr>
-            <a:endParaRPr/>
           </a:p>
           <a:p>
             <a:pPr algn="l">
@@ -4799,7 +4724,7 @@
         <p:spPr>
           <a:xfrm>
             <a:off x="6309360" y="2743200"/>
-            <a:ext cx="5029200" cy="3898275"/>
+            <a:ext cx="5029200" cy="3749039"/>
           </a:xfrm>
           <a:prstGeom prst="roundRect">
             <a:avLst>
@@ -4832,7 +4757,6 @@
           <a:lstStyle/>
           <a:p>
             <a:pPr algn="ctr"/>
-            <a:endParaRPr/>
           </a:p>
         </p:txBody>
       </p:sp>
@@ -4881,7 +4805,7 @@
         <p:spPr>
           <a:xfrm>
             <a:off x="6537960" y="3291840"/>
-            <a:ext cx="4572000" cy="3349635"/>
+            <a:ext cx="4572000" cy="3017520"/>
           </a:xfrm>
           <a:prstGeom prst="rect">
             <a:avLst/>
@@ -4909,7 +4833,6 @@
               </a:defRPr>
             </a:pPr>
             <a:r>
-              <a:rPr dirty="0"/>
               <a:t>11 scenarios spanning hiring, file access, medical</a:t>
             </a:r>
           </a:p>
@@ -4929,7 +4852,6 @@
               </a:defRPr>
             </a:pPr>
             <a:r>
-              <a:rPr dirty="0"/>
               <a:t>  triage, AI deployment, financial decisions</a:t>
             </a:r>
           </a:p>
@@ -4948,7 +4870,6 @@
                 <a:latin typeface="Calibri"/>
               </a:defRPr>
             </a:pPr>
-            <a:endParaRPr sz="1200" dirty="0"/>
           </a:p>
           <a:p>
             <a:pPr algn="l">
@@ -4966,7 +4887,6 @@
               </a:defRPr>
             </a:pPr>
             <a:r>
-              <a:rPr dirty="0"/>
               <a:t>4 vulnerability profiles (BFI-2 grounded):</a:t>
             </a:r>
           </a:p>
@@ -4986,7 +4906,6 @@
               </a:defRPr>
             </a:pPr>
             <a:r>
-              <a:rPr dirty="0"/>
               <a:t>  Idealistic · Compliant · Authority Deferential · Time Pressured</a:t>
             </a:r>
           </a:p>
@@ -5005,7 +4924,6 @@
                 <a:latin typeface="Calibri"/>
               </a:defRPr>
             </a:pPr>
-            <a:endParaRPr sz="1200" dirty="0"/>
           </a:p>
           <a:p>
             <a:pPr algn="l">
@@ -5023,7 +4941,6 @@
               </a:defRPr>
             </a:pPr>
             <a:r>
-              <a:rPr dirty="0"/>
               <a:t>4 model families × 3 capability tiers each</a:t>
             </a:r>
           </a:p>
@@ -5043,7 +4960,6 @@
               </a:defRPr>
             </a:pPr>
             <a:r>
-              <a:rPr dirty="0"/>
               <a:t>  (Gemini Flash, Gemma, Llama, Mistral)</a:t>
             </a:r>
           </a:p>
@@ -5062,7 +4978,6 @@
                 <a:latin typeface="Calibri"/>
               </a:defRPr>
             </a:pPr>
-            <a:endParaRPr dirty="0"/>
           </a:p>
           <a:p>
             <a:pPr algn="l">
@@ -5080,7 +4995,6 @@
               </a:defRPr>
             </a:pPr>
             <a:r>
-              <a:rPr dirty="0"/>
               <a:t>4-turn conversations, forced-choice decision</a:t>
             </a:r>
           </a:p>
@@ -5100,7 +5014,6 @@
               </a:defRPr>
             </a:pPr>
             <a:r>
-              <a:rPr dirty="0"/>
               <a:t>GLMEs with random slopes for warden effect</a:t>
             </a:r>
           </a:p>
@@ -5151,7 +5064,7 @@
 </file>
 
 <file path=ppt/slides/slide3.xml><?xml version="1.0" encoding="utf-8"?>
-<p:sld xmlns:a="http://schemas.openxmlformats.org/drawingml/2006/main" xmlns:r="http://schemas.openxmlformats.org/officeDocument/2006/relationships" xmlns:p="http://schemas.openxmlformats.org/presentationml/2006/main">
+<p:sld xmlns:a="http://schemas.openxmlformats.org/drawingml/2006/main" xmlns:p="http://schemas.openxmlformats.org/presentationml/2006/main" xmlns:r="http://schemas.openxmlformats.org/officeDocument/2006/relationships">
   <p:cSld>
     <p:bg>
       <p:bgPr>
@@ -5167,14 +5080,7 @@
         <p:cNvGrpSpPr/>
         <p:nvPr/>
       </p:nvGrpSpPr>
-      <p:grpSpPr>
-        <a:xfrm>
-          <a:off x="0" y="0"/>
-          <a:ext cx="0" cy="0"/>
-          <a:chOff x="0" y="0"/>
-          <a:chExt cx="0" cy="0"/>
-        </a:xfrm>
-      </p:grpSpPr>
+      <p:grpSpPr/>
       <p:sp>
         <p:nvSpPr>
           <p:cNvPr id="2" name="Rectangle 1"/>
@@ -5215,7 +5121,6 @@
           <a:lstStyle/>
           <a:p>
             <a:pPr algn="ctr"/>
-            <a:endParaRPr/>
           </a:p>
         </p:txBody>
       </p:sp>
@@ -5333,7 +5238,6 @@
           <a:lstStyle/>
           <a:p>
             <a:pPr algn="ctr"/>
-            <a:endParaRPr/>
           </a:p>
         </p:txBody>
       </p:sp>
@@ -5353,8 +5257,8 @@
         </p:blipFill>
         <p:spPr>
           <a:xfrm>
-            <a:off x="676761" y="1143000"/>
-            <a:ext cx="3063240" cy="3063240"/>
+            <a:off x="594360" y="1143000"/>
+            <a:ext cx="3291840" cy="3291840"/>
           </a:xfrm>
           <a:prstGeom prst="rect">
             <a:avLst/>
@@ -5403,7 +5307,6 @@
           <a:lstStyle/>
           <a:p>
             <a:pPr algn="ctr"/>
-            <a:endParaRPr/>
           </a:p>
         </p:txBody>
       </p:sp>
@@ -5510,7 +5413,6 @@
           <a:lstStyle/>
           <a:p>
             <a:pPr algn="ctr"/>
-            <a:endParaRPr/>
           </a:p>
         </p:txBody>
       </p:sp>
@@ -5580,7 +5482,6 @@
           <a:lstStyle/>
           <a:p>
             <a:pPr algn="ctr"/>
-            <a:endParaRPr/>
           </a:p>
         </p:txBody>
       </p:sp>
@@ -5687,7 +5588,6 @@
           <a:lstStyle/>
           <a:p>
             <a:pPr algn="ctr"/>
-            <a:endParaRPr/>
           </a:p>
         </p:txBody>
       </p:sp>
@@ -5757,7 +5657,6 @@
           <a:lstStyle/>
           <a:p>
             <a:pPr algn="ctr"/>
-            <a:endParaRPr/>
           </a:p>
         </p:txBody>
       </p:sp>
@@ -5864,7 +5763,6 @@
           <a:lstStyle/>
           <a:p>
             <a:pPr algn="ctr"/>
-            <a:endParaRPr/>
           </a:p>
         </p:txBody>
       </p:sp>
@@ -6007,7 +5905,6 @@
           <a:lstStyle/>
           <a:p>
             <a:pPr algn="ctr"/>
-            <a:endParaRPr/>
           </a:p>
         </p:txBody>
       </p:sp>
@@ -6150,7 +6047,6 @@
           <a:lstStyle/>
           <a:p>
             <a:pPr algn="ctr"/>
-            <a:endParaRPr/>
           </a:p>
         </p:txBody>
       </p:sp>
@@ -6293,7 +6189,6 @@
           <a:lstStyle/>
           <a:p>
             <a:pPr algn="ctr"/>
-            <a:endParaRPr/>
           </a:p>
         </p:txBody>
       </p:sp>
@@ -6328,7 +6223,6 @@
               </a:defRPr>
             </a:pPr>
             <a:r>
-              <a:rPr dirty="0"/>
               <a:t>3×</a:t>
             </a:r>
           </a:p>
@@ -6440,7 +6334,7 @@
 </file>
 
 <file path=ppt/slides/slide4.xml><?xml version="1.0" encoding="utf-8"?>
-<p:sld xmlns:a="http://schemas.openxmlformats.org/drawingml/2006/main" xmlns:r="http://schemas.openxmlformats.org/officeDocument/2006/relationships" xmlns:p="http://schemas.openxmlformats.org/presentationml/2006/main">
+<p:sld xmlns:a="http://schemas.openxmlformats.org/drawingml/2006/main" xmlns:p="http://schemas.openxmlformats.org/presentationml/2006/main" xmlns:r="http://schemas.openxmlformats.org/officeDocument/2006/relationships">
   <p:cSld>
     <p:bg>
       <p:bgPr>
@@ -6456,14 +6350,7 @@
         <p:cNvGrpSpPr/>
         <p:nvPr/>
       </p:nvGrpSpPr>
-      <p:grpSpPr>
-        <a:xfrm>
-          <a:off x="0" y="0"/>
-          <a:ext cx="0" cy="0"/>
-          <a:chOff x="0" y="0"/>
-          <a:chExt cx="0" cy="0"/>
-        </a:xfrm>
-      </p:grpSpPr>
+      <p:grpSpPr/>
       <p:sp>
         <p:nvSpPr>
           <p:cNvPr id="2" name="Rectangle 1"/>
@@ -6504,7 +6391,6 @@
           <a:lstStyle/>
           <a:p>
             <a:pPr algn="ctr"/>
-            <a:endParaRPr/>
           </a:p>
         </p:txBody>
       </p:sp>
@@ -6586,7 +6472,6 @@
           <a:lstStyle/>
           <a:p>
             <a:pPr algn="ctr"/>
-            <a:endParaRPr/>
           </a:p>
         </p:txBody>
       </p:sp>
@@ -6873,7 +6758,7 @@
               </a:defRPr>
             </a:pPr>
             <a:r>
-              <a:t>5</a:t>
+              <a:t>3</a:t>
             </a:r>
           </a:p>
         </p:txBody>
@@ -7316,7 +7201,6 @@
           <a:lstStyle/>
           <a:p>
             <a:pPr algn="ctr"/>
-            <a:endParaRPr/>
           </a:p>
         </p:txBody>
       </p:sp>
@@ -7580,7 +7464,7 @@
         </p:nvSpPr>
         <p:spPr>
           <a:xfrm>
-            <a:off x="6675120" y="3707124"/>
+            <a:off x="6675120" y="3849624"/>
             <a:ext cx="4572000" cy="274320"/>
           </a:xfrm>
           <a:prstGeom prst="rect">
@@ -7603,7 +7487,6 @@
               </a:defRPr>
             </a:pPr>
             <a:r>
-              <a:rPr dirty="0"/>
               <a:t>▶  Release COAX-Bench</a:t>
             </a:r>
           </a:p>
@@ -7617,7 +7500,7 @@
         </p:nvSpPr>
         <p:spPr>
           <a:xfrm>
-            <a:off x="6949440" y="3981444"/>
+            <a:off x="6949440" y="4123944"/>
             <a:ext cx="4114800" cy="365760"/>
           </a:xfrm>
           <a:prstGeom prst="rect">
@@ -7687,13 +7570,12 @@
           <a:lstStyle/>
           <a:p>
             <a:pPr algn="ctr"/>
-            <a:endParaRPr/>
           </a:p>
         </p:txBody>
       </p:sp>
       <p:pic>
         <p:nvPicPr>
-          <p:cNvPr id="35" name="Picture 34" descr="fig_profile_vulnerability.png"/>
+          <p:cNvPr id="35" name="Picture 34" descr="fig10_warden_intelligence.png"/>
           <p:cNvPicPr>
             <a:picLocks noChangeAspect="1"/>
           </p:cNvPicPr>
@@ -7707,8 +7589,8 @@
         </p:blipFill>
         <p:spPr>
           <a:xfrm>
-            <a:off x="7762631" y="4709160"/>
-            <a:ext cx="2122658" cy="1645920"/>
+            <a:off x="7040880" y="4709160"/>
+            <a:ext cx="2720902" cy="1645920"/>
           </a:xfrm>
           <a:prstGeom prst="rect">
             <a:avLst/>
@@ -7743,470 +7625,6 @@
                   <a:srgbClr val="666677"/>
                 </a:solidFill>
                 <a:latin typeface="Calibri"/>
-              </a:defRPr>
-            </a:pPr>
-            <a:r>
-              <a:t>4</a:t>
-            </a:r>
-          </a:p>
-        </p:txBody>
-      </p:sp>
-    </p:spTree>
-  </p:cSld>
-  <p:clrMapOvr>
-    <a:masterClrMapping/>
-  </p:clrMapOvr>
-</p:sld>
-</file>
-
-<file path=ppt/slides/slide5.xml><?xml version="1.0" encoding="utf-8"?>
-<p:sld xmlns:a="http://schemas.openxmlformats.org/drawingml/2006/main" xmlns:p="http://schemas.openxmlformats.org/presentationml/2006/main" xmlns:r="http://schemas.openxmlformats.org/officeDocument/2006/relationships">
-  <p:cSld>
-    <p:spTree>
-      <p:nvGrpSpPr>
-        <p:cNvPr id="1" name=""/>
-        <p:cNvGrpSpPr/>
-        <p:nvPr/>
-      </p:nvGrpSpPr>
-      <p:grpSpPr/>
-      <p:sp>
-        <p:nvSpPr>
-          <p:cNvPr id="2" name="Rectangle 1"/>
-          <p:cNvSpPr/>
-          <p:nvPr/>
-        </p:nvSpPr>
-        <p:spPr>
-          <a:xfrm>
-            <a:off x="0" y="0"/>
-            <a:ext cx="12188952" cy="73152"/>
-          </a:xfrm>
-          <a:prstGeom prst="rect">
-            <a:avLst/>
-          </a:prstGeom>
-          <a:solidFill>
-            <a:srgbClr val="1A73E8"/>
-          </a:solidFill>
-          <a:ln>
-            <a:noFill/>
-          </a:ln>
-        </p:spPr>
-        <p:style>
-          <a:lnRef idx="1">
-            <a:schemeClr val="accent1"/>
-          </a:lnRef>
-          <a:fillRef idx="3">
-            <a:schemeClr val="accent1"/>
-          </a:fillRef>
-          <a:effectRef idx="2">
-            <a:schemeClr val="accent1"/>
-          </a:effectRef>
-          <a:fontRef idx="minor">
-            <a:schemeClr val="lt1"/>
-          </a:fontRef>
-        </p:style>
-        <p:txBody>
-          <a:bodyPr rtlCol="0" anchor="ctr"/>
-          <a:lstStyle/>
-          <a:p>
-            <a:pPr algn="ctr"/>
-          </a:p>
-        </p:txBody>
-      </p:sp>
-      <p:sp>
-        <p:nvSpPr>
-          <p:cNvPr id="3" name="TextBox 2"/>
-          <p:cNvSpPr txBox="1"/>
-          <p:nvPr/>
-        </p:nvSpPr>
-        <p:spPr>
-          <a:xfrm>
-            <a:off x="822960" y="182880"/>
-            <a:ext cx="7315200" cy="548640"/>
-          </a:xfrm>
-          <a:prstGeom prst="rect">
-            <a:avLst/>
-          </a:prstGeom>
-          <a:noFill/>
-        </p:spPr>
-        <p:txBody>
-          <a:bodyPr wrap="none">
-            <a:spAutoFit/>
-          </a:bodyPr>
-          <a:lstStyle/>
-          <a:p>
-            <a:pPr>
-              <a:defRPr sz="2800" b="1">
-                <a:solidFill>
-                  <a:srgbClr val="333333"/>
-                </a:solidFill>
-              </a:defRPr>
-            </a:pPr>
-            <a:r>
-              <a:t>Results (continued)</a:t>
-            </a:r>
-          </a:p>
-        </p:txBody>
-      </p:sp>
-      <p:sp>
-        <p:nvSpPr>
-          <p:cNvPr id="4" name="TextBox 3"/>
-          <p:cNvSpPr txBox="1"/>
-          <p:nvPr/>
-        </p:nvSpPr>
-        <p:spPr>
-          <a:xfrm>
-            <a:off x="822960" y="640080"/>
-            <a:ext cx="7315200" cy="365760"/>
-          </a:xfrm>
-          <a:prstGeom prst="rect">
-            <a:avLst/>
-          </a:prstGeom>
-          <a:noFill/>
-        </p:spPr>
-        <p:txBody>
-          <a:bodyPr wrap="none">
-            <a:spAutoFit/>
-          </a:bodyPr>
-          <a:lstStyle/>
-          <a:p>
-            <a:pPr>
-              <a:defRPr sz="1400">
-                <a:solidFill>
-                  <a:srgbClr val="666666"/>
-                </a:solidFill>
-              </a:defRPr>
-            </a:pPr>
-            <a:r>
-              <a:t>Model-level and scenario-level variation in adversary success</a:t>
-            </a:r>
-          </a:p>
-        </p:txBody>
-      </p:sp>
-      <p:sp>
-        <p:nvSpPr>
-          <p:cNvPr id="5" name="Rounded Rectangle 4"/>
-          <p:cNvSpPr/>
-          <p:nvPr/>
-        </p:nvSpPr>
-        <p:spPr>
-          <a:xfrm>
-            <a:off x="457200" y="1005840"/>
-            <a:ext cx="5486400" cy="3474720"/>
-          </a:xfrm>
-          <a:prstGeom prst="roundRect">
-            <a:avLst/>
-          </a:prstGeom>
-          <a:solidFill>
-            <a:srgbClr val="F5F5F5"/>
-          </a:solidFill>
-          <a:ln>
-            <a:solidFill>
-              <a:srgbClr val="DDDDDD"/>
-            </a:solidFill>
-          </a:ln>
-        </p:spPr>
-        <p:style>
-          <a:lnRef idx="1">
-            <a:schemeClr val="accent1"/>
-          </a:lnRef>
-          <a:fillRef idx="3">
-            <a:schemeClr val="accent1"/>
-          </a:fillRef>
-          <a:effectRef idx="2">
-            <a:schemeClr val="accent1"/>
-          </a:effectRef>
-          <a:fontRef idx="minor">
-            <a:schemeClr val="lt1"/>
-          </a:fontRef>
-        </p:style>
-        <p:txBody>
-          <a:bodyPr rtlCol="0" anchor="ctr"/>
-          <a:lstStyle/>
-          <a:p>
-            <a:pPr algn="ctr"/>
-          </a:p>
-        </p:txBody>
-      </p:sp>
-      <p:pic>
-        <p:nvPicPr>
-          <p:cNvPr id="6" name="Picture 5" descr="fig9_model_roles.png"/>
-          <p:cNvPicPr>
-            <a:picLocks noChangeAspect="1"/>
-          </p:cNvPicPr>
-          <p:nvPr/>
-        </p:nvPicPr>
-        <p:blipFill>
-          <a:blip r:embed="rId2"/>
-          <a:stretch>
-            <a:fillRect/>
-          </a:stretch>
-        </p:blipFill>
-        <p:spPr>
-          <a:xfrm>
-            <a:off x="640080" y="1097280"/>
-            <a:ext cx="5120640" cy="1817681"/>
-          </a:xfrm>
-          <a:prstGeom prst="rect">
-            <a:avLst/>
-          </a:prstGeom>
-        </p:spPr>
-      </p:pic>
-      <p:sp>
-        <p:nvSpPr>
-          <p:cNvPr id="7" name="Rounded Rectangle 6"/>
-          <p:cNvSpPr/>
-          <p:nvPr/>
-        </p:nvSpPr>
-        <p:spPr>
-          <a:xfrm>
-            <a:off x="457200" y="4663440"/>
-            <a:ext cx="5486400" cy="1097280"/>
-          </a:xfrm>
-          <a:prstGeom prst="roundRect">
-            <a:avLst/>
-          </a:prstGeom>
-          <a:solidFill>
-            <a:srgbClr val="E8F0FE"/>
-          </a:solidFill>
-          <a:ln>
-            <a:solidFill>
-              <a:srgbClr val="DDDDDD"/>
-            </a:solidFill>
-          </a:ln>
-        </p:spPr>
-        <p:style>
-          <a:lnRef idx="1">
-            <a:schemeClr val="accent1"/>
-          </a:lnRef>
-          <a:fillRef idx="3">
-            <a:schemeClr val="accent1"/>
-          </a:fillRef>
-          <a:effectRef idx="2">
-            <a:schemeClr val="accent1"/>
-          </a:effectRef>
-          <a:fontRef idx="minor">
-            <a:schemeClr val="lt1"/>
-          </a:fontRef>
-        </p:style>
-        <p:txBody>
-          <a:bodyPr rtlCol="0" anchor="ctr"/>
-          <a:lstStyle/>
-          <a:p>
-            <a:pPr algn="ctr"/>
-          </a:p>
-        </p:txBody>
-      </p:sp>
-      <p:sp>
-        <p:nvSpPr>
-          <p:cNvPr id="8" name="TextBox 7"/>
-          <p:cNvSpPr txBox="1"/>
-          <p:nvPr/>
-        </p:nvSpPr>
-        <p:spPr>
-          <a:xfrm>
-            <a:off x="640080" y="4754880"/>
-            <a:ext cx="5120640" cy="914400"/>
-          </a:xfrm>
-          <a:prstGeom prst="rect">
-            <a:avLst/>
-          </a:prstGeom>
-          <a:noFill/>
-        </p:spPr>
-        <p:txBody>
-          <a:bodyPr wrap="square">
-            <a:spAutoFit/>
-          </a:bodyPr>
-          <a:lstStyle/>
-          <a:p>
-            <a:pPr>
-              <a:defRPr sz="1100">
-                <a:solidFill>
-                  <a:srgbClr val="333333"/>
-                </a:solidFill>
-              </a:defRPr>
-            </a:pPr>
-            <a:r>
-              <a:t>Gemini Flash (requester) and Flash-Lite (target) show highest attack success; Mistral wardens are most effective defenders</a:t>
-            </a:r>
-          </a:p>
-        </p:txBody>
-      </p:sp>
-      <p:sp>
-        <p:nvSpPr>
-          <p:cNvPr id="9" name="Rounded Rectangle 8"/>
-          <p:cNvSpPr/>
-          <p:nvPr/>
-        </p:nvSpPr>
-        <p:spPr>
-          <a:xfrm>
-            <a:off x="6217920" y="1005840"/>
-            <a:ext cx="5486400" cy="3474720"/>
-          </a:xfrm>
-          <a:prstGeom prst="roundRect">
-            <a:avLst/>
-          </a:prstGeom>
-          <a:solidFill>
-            <a:srgbClr val="F5F5F5"/>
-          </a:solidFill>
-          <a:ln>
-            <a:solidFill>
-              <a:srgbClr val="DDDDDD"/>
-            </a:solidFill>
-          </a:ln>
-        </p:spPr>
-        <p:style>
-          <a:lnRef idx="1">
-            <a:schemeClr val="accent1"/>
-          </a:lnRef>
-          <a:fillRef idx="3">
-            <a:schemeClr val="accent1"/>
-          </a:fillRef>
-          <a:effectRef idx="2">
-            <a:schemeClr val="accent1"/>
-          </a:effectRef>
-          <a:fontRef idx="minor">
-            <a:schemeClr val="lt1"/>
-          </a:fontRef>
-        </p:style>
-        <p:txBody>
-          <a:bodyPr rtlCol="0" anchor="ctr"/>
-          <a:lstStyle/>
-          <a:p>
-            <a:pPr algn="ctr"/>
-          </a:p>
-        </p:txBody>
-      </p:sp>
-      <p:pic>
-        <p:nvPicPr>
-          <p:cNvPr id="10" name="Picture 9" descr="fig10_scenario_profile_heatmap.png"/>
-          <p:cNvPicPr>
-            <a:picLocks noChangeAspect="1"/>
-          </p:cNvPicPr>
-          <p:nvPr/>
-        </p:nvPicPr>
-        <p:blipFill>
-          <a:blip r:embed="rId3"/>
-          <a:stretch>
-            <a:fillRect/>
-          </a:stretch>
-        </p:blipFill>
-        <p:spPr>
-          <a:xfrm>
-            <a:off x="6400800" y="1097280"/>
-            <a:ext cx="5120640" cy="6522802"/>
-          </a:xfrm>
-          <a:prstGeom prst="rect">
-            <a:avLst/>
-          </a:prstGeom>
-        </p:spPr>
-      </p:pic>
-      <p:sp>
-        <p:nvSpPr>
-          <p:cNvPr id="11" name="Rounded Rectangle 10"/>
-          <p:cNvSpPr/>
-          <p:nvPr/>
-        </p:nvSpPr>
-        <p:spPr>
-          <a:xfrm>
-            <a:off x="6217920" y="4663440"/>
-            <a:ext cx="5486400" cy="1097280"/>
-          </a:xfrm>
-          <a:prstGeom prst="roundRect">
-            <a:avLst/>
-          </a:prstGeom>
-          <a:solidFill>
-            <a:srgbClr val="E8F0FE"/>
-          </a:solidFill>
-          <a:ln>
-            <a:solidFill>
-              <a:srgbClr val="DDDDDD"/>
-            </a:solidFill>
-          </a:ln>
-        </p:spPr>
-        <p:style>
-          <a:lnRef idx="1">
-            <a:schemeClr val="accent1"/>
-          </a:lnRef>
-          <a:fillRef idx="3">
-            <a:schemeClr val="accent1"/>
-          </a:fillRef>
-          <a:effectRef idx="2">
-            <a:schemeClr val="accent1"/>
-          </a:effectRef>
-          <a:fontRef idx="minor">
-            <a:schemeClr val="lt1"/>
-          </a:fontRef>
-        </p:style>
-        <p:txBody>
-          <a:bodyPr rtlCol="0" anchor="ctr"/>
-          <a:lstStyle/>
-          <a:p>
-            <a:pPr algn="ctr"/>
-          </a:p>
-        </p:txBody>
-      </p:sp>
-      <p:sp>
-        <p:nvSpPr>
-          <p:cNvPr id="12" name="TextBox 11"/>
-          <p:cNvSpPr txBox="1"/>
-          <p:nvPr/>
-        </p:nvSpPr>
-        <p:spPr>
-          <a:xfrm>
-            <a:off x="6400800" y="4754880"/>
-            <a:ext cx="5120640" cy="914400"/>
-          </a:xfrm>
-          <a:prstGeom prst="rect">
-            <a:avLst/>
-          </a:prstGeom>
-          <a:noFill/>
-        </p:spPr>
-        <p:txBody>
-          <a:bodyPr wrap="square">
-            <a:spAutoFit/>
-          </a:bodyPr>
-          <a:lstStyle/>
-          <a:p>
-            <a:pPr>
-              <a:defRPr sz="1100">
-                <a:solidFill>
-                  <a:srgbClr val="333333"/>
-                </a:solidFill>
-              </a:defRPr>
-            </a:pPr>
-            <a:r>
-              <a:t>Scenario difficulty varies widely; override/vote/file_access most vulnerable, especially for Idealistic and Time-Pressured profiles</a:t>
-            </a:r>
-          </a:p>
-        </p:txBody>
-      </p:sp>
-      <p:sp>
-        <p:nvSpPr>
-          <p:cNvPr id="13" name="TextBox 12"/>
-          <p:cNvSpPr txBox="1"/>
-          <p:nvPr/>
-        </p:nvSpPr>
-        <p:spPr>
-          <a:xfrm>
-            <a:off x="11430000" y="6400800"/>
-            <a:ext cx="548640" cy="274320"/>
-          </a:xfrm>
-          <a:prstGeom prst="rect">
-            <a:avLst/>
-          </a:prstGeom>
-          <a:noFill/>
-        </p:spPr>
-        <p:txBody>
-          <a:bodyPr wrap="none">
-            <a:spAutoFit/>
-          </a:bodyPr>
-          <a:lstStyle/>
-          <a:p>
-            <a:pPr>
-              <a:defRPr sz="1000">
-                <a:solidFill>
-                  <a:srgbClr val="999999"/>
-                </a:solidFill>
               </a:defRPr>
             </a:pPr>
             <a:r>
@@ -8541,10 +7959,4 @@
   </a:objectDefaults>
   <a:extraClrSchemeLst/>
 </a:theme>
-</file>
-
-<file path=docMetadata/LabelInfo.xml><?xml version="1.0" encoding="utf-8"?>
-<clbl:labelList xmlns:clbl="http://schemas.microsoft.com/office/2020/mipLabelMetadata">
-  <clbl:label id="{8db864bc-821c-4dd3-a9c9-5002b5129ec6}" enabled="1" method="Standard" siteId="{0b95a125-791c-4f0a-9f9e-99e363117506}" contentBits="0" removed="0"/>
-</clbl:labelList>
 </file>
</xml_diff>